<commit_message>
Updated PowerPoint presentation with final content
</commit_message>
<xml_diff>
--- a/SQL RESTAURANT & CONSUMER ANALYSIS.pptx
+++ b/SQL RESTAURANT & CONSUMER ANALYSIS.pptx
@@ -273,7 +273,7 @@
       <p15:sldGuideLst xmlns:p15="http://schemas.microsoft.com/office/powerpoint/2012/main"/>
     </p:ext>
     <p:ext uri="GoogleSlidesCustomDataVersion2">
-      <go:slidesCustomData xmlns="" xmlns:mc="http://schemas.openxmlformats.org/markup-compatibility/2006" xmlns:mv="urn:schemas-microsoft-com:mac:vml" xmlns:c="http://schemas.openxmlformats.org/drawingml/2006/chart" xmlns:dgm="http://schemas.openxmlformats.org/drawingml/2006/diagram" xmlns:o="urn:schemas-microsoft-com:office:office" xmlns:v="urn:schemas-microsoft-com:vml" xmlns:pvml="urn:schemas-microsoft-com:office:powerpoint" xmlns:com="http://schemas.openxmlformats.org/drawingml/2006/compatibility" xmlns:p14="http://schemas.microsoft.com/office/powerpoint/2010/main" xmlns:p15="http://schemas.microsoft.com/office/powerpoint/2012/main" xmlns:ahyp="http://schemas.microsoft.com/office/drawing/2018/hyperlinkcolor" xmlns:go="http://customooxmlschemas.google.com/" r:id="rId23" roundtripDataSignature="AMtx7mi4HmEECUlll0m8HTY06QsqsmZGGQ=="/>
+      <go:slidesCustomData xmlns:go="http://customooxmlschemas.google.com/" xmlns:ahyp="http://schemas.microsoft.com/office/drawing/2018/hyperlinkcolor" xmlns:p15="http://schemas.microsoft.com/office/powerpoint/2012/main" xmlns:p14="http://schemas.microsoft.com/office/powerpoint/2010/main" xmlns:com="http://schemas.openxmlformats.org/drawingml/2006/compatibility" xmlns:pvml="urn:schemas-microsoft-com:office:powerpoint" xmlns:v="urn:schemas-microsoft-com:vml" xmlns:o="urn:schemas-microsoft-com:office:office" xmlns:dgm="http://schemas.openxmlformats.org/drawingml/2006/diagram" xmlns:c="http://schemas.openxmlformats.org/drawingml/2006/chart" xmlns:mv="urn:schemas-microsoft-com:mac:vml" xmlns:mc="http://schemas.openxmlformats.org/markup-compatibility/2006" xmlns="" r:id="rId23" roundtripDataSignature="AMtx7mi4HmEECUlll0m8HTY06QsqsmZGGQ=="/>
     </p:ext>
   </p:extLst>
 </p:presentation>
@@ -16832,23 +16832,42 @@
             </a:pPr>
             <a:r>
               <a:rPr lang="en-US" sz="2000" dirty="0"/>
-              <a:t>   LinkedIn: [Your Profile]</a:t>
+              <a:t>   LinkedIn</a:t>
             </a:r>
+            <a:r>
+              <a:rPr lang="en-US" sz="2000"/>
+              <a:t>: </a:t>
+            </a:r>
+            <a:r>
+              <a:rPr lang="en-US" sz="2000">
+                <a:hlinkClick r:id="rId2"/>
+              </a:rPr>
+              <a:t>https://lnkd.in/p/gPNS8Kyp</a:t>
+            </a:r>
+            <a:endParaRPr lang="en-US" sz="2000"/>
           </a:p>
           <a:p>
             <a:pPr marL="114300" indent="0">
               <a:buNone/>
             </a:pPr>
             <a:r>
+              <a:rPr lang="en-US" sz="2000"/>
+              <a:t>   </a:t>
+            </a:r>
+            <a:r>
               <a:rPr lang="en-US" sz="2000" dirty="0"/>
-              <a:t>   GitHub: [Your Repository]</a:t>
+              <a:t>GitHub: </a:t>
             </a:r>
+            <a:r>
+              <a:rPr lang="en-US" sz="2000" dirty="0">
+                <a:hlinkClick r:id="rId3"/>
+              </a:rPr>
+              <a:t>https://github.com/Ramthu-info/SQL-Restaurant-Consumer-Analysis</a:t>
+            </a:r>
+            <a:endParaRPr lang="en-US" sz="2000" dirty="0"/>
           </a:p>
           <a:p>
             <a:pPr marL="114300" indent="0">
-              <a:lnSpc>
-                <a:spcPct val="150000"/>
-              </a:lnSpc>
               <a:buNone/>
             </a:pPr>
             <a:r>

</xml_diff>